<commit_message>
Update classifier and custom features
</commit_message>
<xml_diff>
--- a/ValidationData/validation_results/Initial Results.pptx
+++ b/ValidationData/validation_results/Initial Results.pptx
@@ -5,11 +5,21 @@
     <p:sldMasterId id="2147483648" r:id="rId1"/>
   </p:sldMasterIdLst>
   <p:notesMasterIdLst>
-    <p:notesMasterId r:id="rId4"/>
+    <p:notesMasterId r:id="rId14"/>
   </p:notesMasterIdLst>
   <p:sldIdLst>
     <p:sldId id="257" r:id="rId2"/>
     <p:sldId id="256" r:id="rId3"/>
+    <p:sldId id="259" r:id="rId4"/>
+    <p:sldId id="260" r:id="rId5"/>
+    <p:sldId id="261" r:id="rId6"/>
+    <p:sldId id="258" r:id="rId7"/>
+    <p:sldId id="262" r:id="rId8"/>
+    <p:sldId id="263" r:id="rId9"/>
+    <p:sldId id="264" r:id="rId10"/>
+    <p:sldId id="265" r:id="rId11"/>
+    <p:sldId id="266" r:id="rId12"/>
+    <p:sldId id="267" r:id="rId13"/>
   </p:sldIdLst>
   <p:sldSz cx="12192000" cy="6858000"/>
   <p:notesSz cx="6858000" cy="9144000"/>
@@ -108,6 +118,11 @@
       </a:defRPr>
     </a:lvl9pPr>
   </p:defaultTextStyle>
+  <p:extLst>
+    <p:ext uri="{EFAFB233-063F-42B5-8137-9DF3F51BA10A}">
+      <p15:sldGuideLst xmlns:p15="http://schemas.microsoft.com/office/powerpoint/2012/main"/>
+    </p:ext>
+  </p:extLst>
 </p:presentation>
 </file>
 
@@ -193,7 +208,7 @@
           <a:p>
             <a:fld id="{1F4C38CA-1F73-4745-B567-558B4254ED62}" type="datetimeFigureOut">
               <a:rPr lang="en-US" smtClean="0"/>
-              <a:t>6/11/26</a:t>
+              <a:t>7/1/26</a:t>
             </a:fld>
             <a:endParaRPr lang="en-US"/>
           </a:p>
@@ -775,7 +790,7 @@
           <a:p>
             <a:fld id="{BB3B1590-E60F-AF4C-A55A-6D3A3AAF4CD7}" type="datetimeFigureOut">
               <a:rPr lang="en-US" smtClean="0"/>
-              <a:t>6/11/26</a:t>
+              <a:t>7/1/26</a:t>
             </a:fld>
             <a:endParaRPr lang="en-US"/>
           </a:p>
@@ -973,7 +988,7 @@
           <a:p>
             <a:fld id="{BB3B1590-E60F-AF4C-A55A-6D3A3AAF4CD7}" type="datetimeFigureOut">
               <a:rPr lang="en-US" smtClean="0"/>
-              <a:t>6/11/26</a:t>
+              <a:t>7/1/26</a:t>
             </a:fld>
             <a:endParaRPr lang="en-US"/>
           </a:p>
@@ -1181,7 +1196,7 @@
           <a:p>
             <a:fld id="{BB3B1590-E60F-AF4C-A55A-6D3A3AAF4CD7}" type="datetimeFigureOut">
               <a:rPr lang="en-US" smtClean="0"/>
-              <a:t>6/11/26</a:t>
+              <a:t>7/1/26</a:t>
             </a:fld>
             <a:endParaRPr lang="en-US"/>
           </a:p>
@@ -1379,7 +1394,7 @@
           <a:p>
             <a:fld id="{BB3B1590-E60F-AF4C-A55A-6D3A3AAF4CD7}" type="datetimeFigureOut">
               <a:rPr lang="en-US" smtClean="0"/>
-              <a:t>6/11/26</a:t>
+              <a:t>7/1/26</a:t>
             </a:fld>
             <a:endParaRPr lang="en-US"/>
           </a:p>
@@ -1654,7 +1669,7 @@
           <a:p>
             <a:fld id="{BB3B1590-E60F-AF4C-A55A-6D3A3AAF4CD7}" type="datetimeFigureOut">
               <a:rPr lang="en-US" smtClean="0"/>
-              <a:t>6/11/26</a:t>
+              <a:t>7/1/26</a:t>
             </a:fld>
             <a:endParaRPr lang="en-US"/>
           </a:p>
@@ -1919,7 +1934,7 @@
           <a:p>
             <a:fld id="{BB3B1590-E60F-AF4C-A55A-6D3A3AAF4CD7}" type="datetimeFigureOut">
               <a:rPr lang="en-US" smtClean="0"/>
-              <a:t>6/11/26</a:t>
+              <a:t>7/1/26</a:t>
             </a:fld>
             <a:endParaRPr lang="en-US"/>
           </a:p>
@@ -2331,7 +2346,7 @@
           <a:p>
             <a:fld id="{BB3B1590-E60F-AF4C-A55A-6D3A3AAF4CD7}" type="datetimeFigureOut">
               <a:rPr lang="en-US" smtClean="0"/>
-              <a:t>6/11/26</a:t>
+              <a:t>7/1/26</a:t>
             </a:fld>
             <a:endParaRPr lang="en-US"/>
           </a:p>
@@ -2472,7 +2487,7 @@
           <a:p>
             <a:fld id="{BB3B1590-E60F-AF4C-A55A-6D3A3AAF4CD7}" type="datetimeFigureOut">
               <a:rPr lang="en-US" smtClean="0"/>
-              <a:t>6/11/26</a:t>
+              <a:t>7/1/26</a:t>
             </a:fld>
             <a:endParaRPr lang="en-US"/>
           </a:p>
@@ -2585,7 +2600,7 @@
           <a:p>
             <a:fld id="{BB3B1590-E60F-AF4C-A55A-6D3A3AAF4CD7}" type="datetimeFigureOut">
               <a:rPr lang="en-US" smtClean="0"/>
-              <a:t>6/11/26</a:t>
+              <a:t>7/1/26</a:t>
             </a:fld>
             <a:endParaRPr lang="en-US"/>
           </a:p>
@@ -2896,7 +2911,7 @@
           <a:p>
             <a:fld id="{BB3B1590-E60F-AF4C-A55A-6D3A3AAF4CD7}" type="datetimeFigureOut">
               <a:rPr lang="en-US" smtClean="0"/>
-              <a:t>6/11/26</a:t>
+              <a:t>7/1/26</a:t>
             </a:fld>
             <a:endParaRPr lang="en-US"/>
           </a:p>
@@ -3184,7 +3199,7 @@
           <a:p>
             <a:fld id="{BB3B1590-E60F-AF4C-A55A-6D3A3AAF4CD7}" type="datetimeFigureOut">
               <a:rPr lang="en-US" smtClean="0"/>
-              <a:t>6/11/26</a:t>
+              <a:t>7/1/26</a:t>
             </a:fld>
             <a:endParaRPr lang="en-US"/>
           </a:p>
@@ -3425,7 +3440,7 @@
           <a:p>
             <a:fld id="{BB3B1590-E60F-AF4C-A55A-6D3A3AAF4CD7}" type="datetimeFigureOut">
               <a:rPr lang="en-US" smtClean="0"/>
-              <a:t>6/11/26</a:t>
+              <a:t>7/1/26</a:t>
             </a:fld>
             <a:endParaRPr lang="en-US"/>
           </a:p>
@@ -3997,6 +4012,598 @@
 </p:sld>
 </file>
 
+<file path=ppt/slides/slide10.xml><?xml version="1.0" encoding="utf-8"?>
+<p:sld xmlns:a="http://schemas.openxmlformats.org/drawingml/2006/main" xmlns:r="http://schemas.openxmlformats.org/officeDocument/2006/relationships" xmlns:p="http://schemas.openxmlformats.org/presentationml/2006/main">
+  <p:cSld>
+    <p:spTree>
+      <p:nvGrpSpPr>
+        <p:cNvPr id="1" name=""/>
+        <p:cNvGrpSpPr/>
+        <p:nvPr/>
+      </p:nvGrpSpPr>
+      <p:grpSpPr>
+        <a:xfrm>
+          <a:off x="0" y="0"/>
+          <a:ext cx="0" cy="0"/>
+          <a:chOff x="0" y="0"/>
+          <a:chExt cx="0" cy="0"/>
+        </a:xfrm>
+      </p:grpSpPr>
+      <p:pic>
+        <p:nvPicPr>
+          <p:cNvPr id="5" name="Picture 4">
+            <a:extLst>
+              <a:ext uri="{FF2B5EF4-FFF2-40B4-BE49-F238E27FC236}">
+                <a16:creationId xmlns:a16="http://schemas.microsoft.com/office/drawing/2014/main" id="{A3544D47-F570-7EDB-5D5E-1B9C2B119464}"/>
+              </a:ext>
+            </a:extLst>
+          </p:cNvPr>
+          <p:cNvPicPr>
+            <a:picLocks noChangeAspect="1"/>
+          </p:cNvPicPr>
+          <p:nvPr/>
+        </p:nvPicPr>
+        <p:blipFill>
+          <a:blip r:embed="rId2"/>
+          <a:stretch>
+            <a:fillRect/>
+          </a:stretch>
+        </p:blipFill>
+        <p:spPr>
+          <a:xfrm>
+            <a:off x="2682240" y="502920"/>
+            <a:ext cx="6827520" cy="5852160"/>
+          </a:xfrm>
+          <a:prstGeom prst="rect">
+            <a:avLst/>
+          </a:prstGeom>
+        </p:spPr>
+      </p:pic>
+    </p:spTree>
+    <p:extLst>
+      <p:ext uri="{BB962C8B-B14F-4D97-AF65-F5344CB8AC3E}">
+        <p14:creationId xmlns:p14="http://schemas.microsoft.com/office/powerpoint/2010/main" val="1163657647"/>
+      </p:ext>
+    </p:extLst>
+  </p:cSld>
+  <p:clrMapOvr>
+    <a:masterClrMapping/>
+  </p:clrMapOvr>
+</p:sld>
+</file>
+
+<file path=ppt/slides/slide11.xml><?xml version="1.0" encoding="utf-8"?>
+<p:sld xmlns:a="http://schemas.openxmlformats.org/drawingml/2006/main" xmlns:r="http://schemas.openxmlformats.org/officeDocument/2006/relationships" xmlns:p="http://schemas.openxmlformats.org/presentationml/2006/main">
+  <p:cSld>
+    <p:spTree>
+      <p:nvGrpSpPr>
+        <p:cNvPr id="1" name=""/>
+        <p:cNvGrpSpPr/>
+        <p:nvPr/>
+      </p:nvGrpSpPr>
+      <p:grpSpPr>
+        <a:xfrm>
+          <a:off x="0" y="0"/>
+          <a:ext cx="0" cy="0"/>
+          <a:chOff x="0" y="0"/>
+          <a:chExt cx="0" cy="0"/>
+        </a:xfrm>
+      </p:grpSpPr>
+      <p:sp>
+        <p:nvSpPr>
+          <p:cNvPr id="4" name="TextBox 3">
+            <a:extLst>
+              <a:ext uri="{FF2B5EF4-FFF2-40B4-BE49-F238E27FC236}">
+                <a16:creationId xmlns:a16="http://schemas.microsoft.com/office/drawing/2014/main" id="{E95C9839-EB7D-756E-E2CA-9FCF7A6007CD}"/>
+              </a:ext>
+            </a:extLst>
+          </p:cNvPr>
+          <p:cNvSpPr txBox="1"/>
+          <p:nvPr/>
+        </p:nvSpPr>
+        <p:spPr>
+          <a:xfrm>
+            <a:off x="83681" y="3196828"/>
+            <a:ext cx="2698239" cy="400110"/>
+          </a:xfrm>
+          <a:prstGeom prst="rect">
+            <a:avLst/>
+          </a:prstGeom>
+          <a:noFill/>
+        </p:spPr>
+        <p:txBody>
+          <a:bodyPr wrap="none" rtlCol="0">
+            <a:spAutoFit/>
+          </a:bodyPr>
+          <a:lstStyle/>
+          <a:p>
+            <a:r>
+              <a:rPr lang="en-US" sz="2000" b="1" dirty="0"/>
+              <a:t>Pre-selected pictures</a:t>
+            </a:r>
+          </a:p>
+        </p:txBody>
+      </p:sp>
+      <p:pic>
+        <p:nvPicPr>
+          <p:cNvPr id="14" name="Picture 13" descr="A chart with different colored squares&#10;&#10;Description automatically generated">
+            <a:extLst>
+              <a:ext uri="{FF2B5EF4-FFF2-40B4-BE49-F238E27FC236}">
+                <a16:creationId xmlns:a16="http://schemas.microsoft.com/office/drawing/2014/main" id="{B3A066CC-166E-B9D7-718C-9715C86350ED}"/>
+              </a:ext>
+            </a:extLst>
+          </p:cNvPr>
+          <p:cNvPicPr>
+            <a:picLocks noChangeAspect="1"/>
+          </p:cNvPicPr>
+          <p:nvPr/>
+        </p:nvPicPr>
+        <p:blipFill>
+          <a:blip r:embed="rId2"/>
+          <a:stretch>
+            <a:fillRect/>
+          </a:stretch>
+        </p:blipFill>
+        <p:spPr>
+          <a:xfrm>
+            <a:off x="3225163" y="0"/>
+            <a:ext cx="4279392" cy="3566160"/>
+          </a:xfrm>
+          <a:prstGeom prst="rect">
+            <a:avLst/>
+          </a:prstGeom>
+        </p:spPr>
+      </p:pic>
+      <p:pic>
+        <p:nvPicPr>
+          <p:cNvPr id="16" name="Picture 15" descr="A graph with blue and white text&#10;&#10;Description automatically generated">
+            <a:extLst>
+              <a:ext uri="{FF2B5EF4-FFF2-40B4-BE49-F238E27FC236}">
+                <a16:creationId xmlns:a16="http://schemas.microsoft.com/office/drawing/2014/main" id="{A2EDAC5B-BB9E-AD61-D288-EAC88604152E}"/>
+              </a:ext>
+            </a:extLst>
+          </p:cNvPr>
+          <p:cNvPicPr>
+            <a:picLocks noChangeAspect="1"/>
+          </p:cNvPicPr>
+          <p:nvPr/>
+        </p:nvPicPr>
+        <p:blipFill>
+          <a:blip r:embed="rId3"/>
+          <a:stretch>
+            <a:fillRect/>
+          </a:stretch>
+        </p:blipFill>
+        <p:spPr>
+          <a:xfrm>
+            <a:off x="3254477" y="3566160"/>
+            <a:ext cx="4114800" cy="3291840"/>
+          </a:xfrm>
+          <a:prstGeom prst="rect">
+            <a:avLst/>
+          </a:prstGeom>
+        </p:spPr>
+      </p:pic>
+      <p:pic>
+        <p:nvPicPr>
+          <p:cNvPr id="18" name="Picture 17" descr="A chart with different colored squares&#10;&#10;Description automatically generated">
+            <a:extLst>
+              <a:ext uri="{FF2B5EF4-FFF2-40B4-BE49-F238E27FC236}">
+                <a16:creationId xmlns:a16="http://schemas.microsoft.com/office/drawing/2014/main" id="{FCB167C6-2BF8-B365-E769-8766C821EC6B}"/>
+              </a:ext>
+            </a:extLst>
+          </p:cNvPr>
+          <p:cNvPicPr>
+            <a:picLocks noChangeAspect="1"/>
+          </p:cNvPicPr>
+          <p:nvPr/>
+        </p:nvPicPr>
+        <p:blipFill>
+          <a:blip r:embed="rId4"/>
+          <a:stretch>
+            <a:fillRect/>
+          </a:stretch>
+        </p:blipFill>
+        <p:spPr>
+          <a:xfrm>
+            <a:off x="7947799" y="0"/>
+            <a:ext cx="4160520" cy="3566160"/>
+          </a:xfrm>
+          <a:prstGeom prst="rect">
+            <a:avLst/>
+          </a:prstGeom>
+        </p:spPr>
+      </p:pic>
+      <p:pic>
+        <p:nvPicPr>
+          <p:cNvPr id="20" name="Picture 19" descr="A graph with text and numbers&#10;&#10;Description automatically generated with medium confidence">
+            <a:extLst>
+              <a:ext uri="{FF2B5EF4-FFF2-40B4-BE49-F238E27FC236}">
+                <a16:creationId xmlns:a16="http://schemas.microsoft.com/office/drawing/2014/main" id="{FC10C24D-9049-A0DA-35D1-5FDAEFDF793C}"/>
+              </a:ext>
+            </a:extLst>
+          </p:cNvPr>
+          <p:cNvPicPr>
+            <a:picLocks noChangeAspect="1"/>
+          </p:cNvPicPr>
+          <p:nvPr/>
+        </p:nvPicPr>
+        <p:blipFill>
+          <a:blip r:embed="rId5"/>
+          <a:stretch>
+            <a:fillRect/>
+          </a:stretch>
+        </p:blipFill>
+        <p:spPr>
+          <a:xfrm>
+            <a:off x="7841835" y="3566160"/>
+            <a:ext cx="4114800" cy="3291840"/>
+          </a:xfrm>
+          <a:prstGeom prst="rect">
+            <a:avLst/>
+          </a:prstGeom>
+        </p:spPr>
+      </p:pic>
+    </p:spTree>
+    <p:extLst>
+      <p:ext uri="{BB962C8B-B14F-4D97-AF65-F5344CB8AC3E}">
+        <p14:creationId xmlns:p14="http://schemas.microsoft.com/office/powerpoint/2010/main" val="3659882589"/>
+      </p:ext>
+    </p:extLst>
+  </p:cSld>
+  <p:clrMapOvr>
+    <a:masterClrMapping/>
+  </p:clrMapOvr>
+</p:sld>
+</file>
+
+<file path=ppt/slides/slide12.xml><?xml version="1.0" encoding="utf-8"?>
+<p:sld xmlns:a="http://schemas.openxmlformats.org/drawingml/2006/main" xmlns:r="http://schemas.openxmlformats.org/officeDocument/2006/relationships" xmlns:p="http://schemas.openxmlformats.org/presentationml/2006/main">
+  <p:cSld>
+    <p:spTree>
+      <p:nvGrpSpPr>
+        <p:cNvPr id="1" name=""/>
+        <p:cNvGrpSpPr/>
+        <p:nvPr/>
+      </p:nvGrpSpPr>
+      <p:grpSpPr>
+        <a:xfrm>
+          <a:off x="0" y="0"/>
+          <a:ext cx="0" cy="0"/>
+          <a:chOff x="0" y="0"/>
+          <a:chExt cx="0" cy="0"/>
+        </a:xfrm>
+      </p:grpSpPr>
+      <p:graphicFrame>
+        <p:nvGraphicFramePr>
+          <p:cNvPr id="6" name="Table 5">
+            <a:extLst>
+              <a:ext uri="{FF2B5EF4-FFF2-40B4-BE49-F238E27FC236}">
+                <a16:creationId xmlns:a16="http://schemas.microsoft.com/office/drawing/2014/main" id="{478AD603-43B2-7149-0A54-DC1EB157EE6E}"/>
+              </a:ext>
+            </a:extLst>
+          </p:cNvPr>
+          <p:cNvGraphicFramePr>
+            <a:graphicFrameLocks noGrp="1"/>
+          </p:cNvGraphicFramePr>
+          <p:nvPr>
+            <p:extLst>
+              <p:ext uri="{D42A27DB-BD31-4B8C-83A1-F6EECF244321}">
+                <p14:modId xmlns:p14="http://schemas.microsoft.com/office/powerpoint/2010/main" val="3491800606"/>
+              </p:ext>
+            </p:extLst>
+          </p:nvPr>
+        </p:nvGraphicFramePr>
+        <p:xfrm>
+          <a:off x="1557439" y="4782379"/>
+          <a:ext cx="8127999" cy="1854200"/>
+        </p:xfrm>
+        <a:graphic>
+          <a:graphicData uri="http://schemas.openxmlformats.org/drawingml/2006/table">
+            <a:tbl>
+              <a:tblPr firstRow="1" bandRow="1">
+                <a:tableStyleId>{5940675A-B579-460E-94D1-54222C63F5DA}</a:tableStyleId>
+              </a:tblPr>
+              <a:tblGrid>
+                <a:gridCol w="2709333">
+                  <a:extLst>
+                    <a:ext uri="{9D8B030D-6E8A-4147-A177-3AD203B41FA5}">
+                      <a16:colId xmlns:a16="http://schemas.microsoft.com/office/drawing/2014/main" val="2812055538"/>
+                    </a:ext>
+                  </a:extLst>
+                </a:gridCol>
+                <a:gridCol w="2709333">
+                  <a:extLst>
+                    <a:ext uri="{9D8B030D-6E8A-4147-A177-3AD203B41FA5}">
+                      <a16:colId xmlns:a16="http://schemas.microsoft.com/office/drawing/2014/main" val="1324112507"/>
+                    </a:ext>
+                  </a:extLst>
+                </a:gridCol>
+                <a:gridCol w="2709333">
+                  <a:extLst>
+                    <a:ext uri="{9D8B030D-6E8A-4147-A177-3AD203B41FA5}">
+                      <a16:colId xmlns:a16="http://schemas.microsoft.com/office/drawing/2014/main" val="2726949454"/>
+                    </a:ext>
+                  </a:extLst>
+                </a:gridCol>
+              </a:tblGrid>
+              <a:tr h="370840">
+                <a:tc>
+                  <a:txBody>
+                    <a:bodyPr/>
+                    <a:lstStyle/>
+                    <a:p>
+                      <a:r>
+                        <a:rPr lang="en-US" dirty="0"/>
+                        <a:t>Crenated</a:t>
+                      </a:r>
+                    </a:p>
+                  </a:txBody>
+                  <a:tcPr/>
+                </a:tc>
+                <a:tc>
+                  <a:txBody>
+                    <a:bodyPr/>
+                    <a:lstStyle/>
+                    <a:p>
+                      <a:r>
+                        <a:rPr lang="en-US" dirty="0"/>
+                        <a:t>96/99</a:t>
+                      </a:r>
+                    </a:p>
+                  </a:txBody>
+                  <a:tcPr/>
+                </a:tc>
+                <a:tc>
+                  <a:txBody>
+                    <a:bodyPr/>
+                    <a:lstStyle/>
+                    <a:p>
+                      <a:r>
+                        <a:rPr lang="en-US" dirty="0"/>
+                        <a:t>97 %</a:t>
+                      </a:r>
+                    </a:p>
+                  </a:txBody>
+                  <a:tcPr/>
+                </a:tc>
+                <a:extLst>
+                  <a:ext uri="{0D108BD9-81ED-4DB2-BD59-A6C34878D82A}">
+                    <a16:rowId xmlns:a16="http://schemas.microsoft.com/office/drawing/2014/main" val="962375959"/>
+                  </a:ext>
+                </a:extLst>
+              </a:tr>
+              <a:tr h="370840">
+                <a:tc>
+                  <a:txBody>
+                    <a:bodyPr/>
+                    <a:lstStyle/>
+                    <a:p>
+                      <a:r>
+                        <a:rPr lang="en-US" dirty="0"/>
+                        <a:t>Dead</a:t>
+                      </a:r>
+                    </a:p>
+                  </a:txBody>
+                  <a:tcPr/>
+                </a:tc>
+                <a:tc>
+                  <a:txBody>
+                    <a:bodyPr/>
+                    <a:lstStyle/>
+                    <a:p>
+                      <a:r>
+                        <a:rPr lang="en-US" dirty="0"/>
+                        <a:t>146/147</a:t>
+                      </a:r>
+                    </a:p>
+                  </a:txBody>
+                  <a:tcPr/>
+                </a:tc>
+                <a:tc>
+                  <a:txBody>
+                    <a:bodyPr/>
+                    <a:lstStyle/>
+                    <a:p>
+                      <a:r>
+                        <a:rPr lang="en-US" dirty="0"/>
+                        <a:t>99 %</a:t>
+                      </a:r>
+                    </a:p>
+                  </a:txBody>
+                  <a:tcPr/>
+                </a:tc>
+                <a:extLst>
+                  <a:ext uri="{0D108BD9-81ED-4DB2-BD59-A6C34878D82A}">
+                    <a16:rowId xmlns:a16="http://schemas.microsoft.com/office/drawing/2014/main" val="3350298466"/>
+                  </a:ext>
+                </a:extLst>
+              </a:tr>
+              <a:tr h="370840">
+                <a:tc>
+                  <a:txBody>
+                    <a:bodyPr/>
+                    <a:lstStyle/>
+                    <a:p>
+                      <a:r>
+                        <a:rPr lang="en-US" dirty="0"/>
+                        <a:t>Healthy</a:t>
+                      </a:r>
+                    </a:p>
+                  </a:txBody>
+                  <a:tcPr/>
+                </a:tc>
+                <a:tc>
+                  <a:txBody>
+                    <a:bodyPr/>
+                    <a:lstStyle/>
+                    <a:p>
+                      <a:r>
+                        <a:rPr lang="en-US" dirty="0"/>
+                        <a:t>115/146</a:t>
+                      </a:r>
+                    </a:p>
+                  </a:txBody>
+                  <a:tcPr/>
+                </a:tc>
+                <a:tc>
+                  <a:txBody>
+                    <a:bodyPr/>
+                    <a:lstStyle/>
+                    <a:p>
+                      <a:r>
+                        <a:rPr lang="en-US" dirty="0"/>
+                        <a:t>79 %</a:t>
+                      </a:r>
+                    </a:p>
+                  </a:txBody>
+                  <a:tcPr/>
+                </a:tc>
+                <a:extLst>
+                  <a:ext uri="{0D108BD9-81ED-4DB2-BD59-A6C34878D82A}">
+                    <a16:rowId xmlns:a16="http://schemas.microsoft.com/office/drawing/2014/main" val="767047742"/>
+                  </a:ext>
+                </a:extLst>
+              </a:tr>
+              <a:tr h="370840">
+                <a:tc>
+                  <a:txBody>
+                    <a:bodyPr/>
+                    <a:lstStyle/>
+                    <a:p>
+                      <a:r>
+                        <a:rPr lang="en-US" dirty="0"/>
+                        <a:t>Stressed</a:t>
+                      </a:r>
+                    </a:p>
+                  </a:txBody>
+                  <a:tcPr/>
+                </a:tc>
+                <a:tc>
+                  <a:txBody>
+                    <a:bodyPr/>
+                    <a:lstStyle/>
+                    <a:p>
+                      <a:r>
+                        <a:rPr lang="en-US" dirty="0"/>
+                        <a:t>119/150</a:t>
+                      </a:r>
+                    </a:p>
+                  </a:txBody>
+                  <a:tcPr/>
+                </a:tc>
+                <a:tc>
+                  <a:txBody>
+                    <a:bodyPr/>
+                    <a:lstStyle/>
+                    <a:p>
+                      <a:r>
+                        <a:rPr lang="en-US" dirty="0"/>
+                        <a:t>79 %</a:t>
+                      </a:r>
+                    </a:p>
+                  </a:txBody>
+                  <a:tcPr/>
+                </a:tc>
+                <a:extLst>
+                  <a:ext uri="{0D108BD9-81ED-4DB2-BD59-A6C34878D82A}">
+                    <a16:rowId xmlns:a16="http://schemas.microsoft.com/office/drawing/2014/main" val="518758537"/>
+                  </a:ext>
+                </a:extLst>
+              </a:tr>
+              <a:tr h="370840">
+                <a:tc>
+                  <a:txBody>
+                    <a:bodyPr/>
+                    <a:lstStyle/>
+                    <a:p>
+                      <a:r>
+                        <a:rPr lang="en-US" dirty="0"/>
+                        <a:t>Non-healthy</a:t>
+                      </a:r>
+                    </a:p>
+                  </a:txBody>
+                  <a:tcPr/>
+                </a:tc>
+                <a:tc>
+                  <a:txBody>
+                    <a:bodyPr/>
+                    <a:lstStyle/>
+                    <a:p>
+                      <a:r>
+                        <a:rPr lang="en-US" dirty="0"/>
+                        <a:t>361/396</a:t>
+                      </a:r>
+                    </a:p>
+                  </a:txBody>
+                  <a:tcPr/>
+                </a:tc>
+                <a:tc>
+                  <a:txBody>
+                    <a:bodyPr/>
+                    <a:lstStyle/>
+                    <a:p>
+                      <a:r>
+                        <a:rPr lang="en-US" dirty="0"/>
+                        <a:t>91 %</a:t>
+                      </a:r>
+                    </a:p>
+                  </a:txBody>
+                  <a:tcPr/>
+                </a:tc>
+                <a:extLst>
+                  <a:ext uri="{0D108BD9-81ED-4DB2-BD59-A6C34878D82A}">
+                    <a16:rowId xmlns:a16="http://schemas.microsoft.com/office/drawing/2014/main" val="3747011061"/>
+                  </a:ext>
+                </a:extLst>
+              </a:tr>
+            </a:tbl>
+          </a:graphicData>
+        </a:graphic>
+      </p:graphicFrame>
+      <p:pic>
+        <p:nvPicPr>
+          <p:cNvPr id="8" name="Picture 7" descr="A colorful squares with white text&#10;&#10;Description automatically generated">
+            <a:extLst>
+              <a:ext uri="{FF2B5EF4-FFF2-40B4-BE49-F238E27FC236}">
+                <a16:creationId xmlns:a16="http://schemas.microsoft.com/office/drawing/2014/main" id="{331CC872-D24C-85B2-5AFB-C0E447BB36C5}"/>
+              </a:ext>
+            </a:extLst>
+          </p:cNvPr>
+          <p:cNvPicPr>
+            <a:picLocks noChangeAspect="1"/>
+          </p:cNvPicPr>
+          <p:nvPr/>
+        </p:nvPicPr>
+        <p:blipFill>
+          <a:blip r:embed="rId2"/>
+          <a:stretch>
+            <a:fillRect/>
+          </a:stretch>
+        </p:blipFill>
+        <p:spPr>
+          <a:xfrm>
+            <a:off x="2901098" y="0"/>
+            <a:ext cx="5440680" cy="4663440"/>
+          </a:xfrm>
+          <a:prstGeom prst="rect">
+            <a:avLst/>
+          </a:prstGeom>
+        </p:spPr>
+      </p:pic>
+    </p:spTree>
+    <p:extLst>
+      <p:ext uri="{BB962C8B-B14F-4D97-AF65-F5344CB8AC3E}">
+        <p14:creationId xmlns:p14="http://schemas.microsoft.com/office/powerpoint/2010/main" val="3677255918"/>
+      </p:ext>
+    </p:extLst>
+  </p:cSld>
+  <p:clrMapOvr>
+    <a:masterClrMapping/>
+  </p:clrMapOvr>
+</p:sld>
+</file>
+
 <file path=ppt/slides/slide2.xml><?xml version="1.0" encoding="utf-8"?>
 <p:sld xmlns:a="http://schemas.openxmlformats.org/drawingml/2006/main" xmlns:r="http://schemas.openxmlformats.org/officeDocument/2006/relationships" xmlns:p="http://schemas.openxmlformats.org/presentationml/2006/main">
   <p:cSld>
@@ -4160,6 +4767,924 @@
     <p:extLst>
       <p:ext uri="{BB962C8B-B14F-4D97-AF65-F5344CB8AC3E}">
         <p14:creationId xmlns:p14="http://schemas.microsoft.com/office/powerpoint/2010/main" val="3973402697"/>
+      </p:ext>
+    </p:extLst>
+  </p:cSld>
+  <p:clrMapOvr>
+    <a:masterClrMapping/>
+  </p:clrMapOvr>
+</p:sld>
+</file>
+
+<file path=ppt/slides/slide3.xml><?xml version="1.0" encoding="utf-8"?>
+<p:sld xmlns:a="http://schemas.openxmlformats.org/drawingml/2006/main" xmlns:r="http://schemas.openxmlformats.org/officeDocument/2006/relationships" xmlns:p="http://schemas.openxmlformats.org/presentationml/2006/main">
+  <p:cSld>
+    <p:spTree>
+      <p:nvGrpSpPr>
+        <p:cNvPr id="1" name=""/>
+        <p:cNvGrpSpPr/>
+        <p:nvPr/>
+      </p:nvGrpSpPr>
+      <p:grpSpPr>
+        <a:xfrm>
+          <a:off x="0" y="0"/>
+          <a:ext cx="0" cy="0"/>
+          <a:chOff x="0" y="0"/>
+          <a:chExt cx="0" cy="0"/>
+        </a:xfrm>
+      </p:grpSpPr>
+      <p:sp>
+        <p:nvSpPr>
+          <p:cNvPr id="2" name="Title 1">
+            <a:extLst>
+              <a:ext uri="{FF2B5EF4-FFF2-40B4-BE49-F238E27FC236}">
+                <a16:creationId xmlns:a16="http://schemas.microsoft.com/office/drawing/2014/main" id="{21024EB3-6D1E-58E9-C1D2-597BFACD463E}"/>
+              </a:ext>
+            </a:extLst>
+          </p:cNvPr>
+          <p:cNvSpPr>
+            <a:spLocks noGrp="1"/>
+          </p:cNvSpPr>
+          <p:nvPr>
+            <p:ph type="title"/>
+          </p:nvPr>
+        </p:nvSpPr>
+        <p:spPr/>
+        <p:txBody>
+          <a:bodyPr/>
+          <a:lstStyle/>
+          <a:p>
+            <a:endParaRPr lang="en-US"/>
+          </a:p>
+        </p:txBody>
+      </p:sp>
+      <p:pic>
+        <p:nvPicPr>
+          <p:cNvPr id="6" name="Content Placeholder 5" descr="A graph with blue and white text&#10;&#10;Description automatically generated">
+            <a:extLst>
+              <a:ext uri="{FF2B5EF4-FFF2-40B4-BE49-F238E27FC236}">
+                <a16:creationId xmlns:a16="http://schemas.microsoft.com/office/drawing/2014/main" id="{6018CF08-F1BA-A788-B596-BA878AA3DBE6}"/>
+              </a:ext>
+            </a:extLst>
+          </p:cNvPr>
+          <p:cNvPicPr>
+            <a:picLocks noGrp="1" noChangeAspect="1"/>
+          </p:cNvPicPr>
+          <p:nvPr>
+            <p:ph idx="1"/>
+          </p:nvPr>
+        </p:nvPicPr>
+        <p:blipFill>
+          <a:blip r:embed="rId2"/>
+          <a:stretch>
+            <a:fillRect/>
+          </a:stretch>
+        </p:blipFill>
+        <p:spPr>
+          <a:xfrm>
+            <a:off x="6649839" y="1594131"/>
+            <a:ext cx="5439172" cy="4351338"/>
+          </a:xfrm>
+        </p:spPr>
+      </p:pic>
+      <p:pic>
+        <p:nvPicPr>
+          <p:cNvPr id="4" name="Picture 3">
+            <a:extLst>
+              <a:ext uri="{FF2B5EF4-FFF2-40B4-BE49-F238E27FC236}">
+                <a16:creationId xmlns:a16="http://schemas.microsoft.com/office/drawing/2014/main" id="{8F89167E-7143-DD76-278A-C5B1301E1602}"/>
+              </a:ext>
+            </a:extLst>
+          </p:cNvPr>
+          <p:cNvPicPr>
+            <a:picLocks noChangeAspect="1"/>
+          </p:cNvPicPr>
+          <p:nvPr/>
+        </p:nvPicPr>
+        <p:blipFill>
+          <a:blip r:embed="rId3"/>
+          <a:stretch>
+            <a:fillRect/>
+          </a:stretch>
+        </p:blipFill>
+        <p:spPr>
+          <a:xfrm>
+            <a:off x="102989" y="866231"/>
+            <a:ext cx="6400800" cy="5486400"/>
+          </a:xfrm>
+          <a:prstGeom prst="rect">
+            <a:avLst/>
+          </a:prstGeom>
+        </p:spPr>
+      </p:pic>
+    </p:spTree>
+    <p:extLst>
+      <p:ext uri="{BB962C8B-B14F-4D97-AF65-F5344CB8AC3E}">
+        <p14:creationId xmlns:p14="http://schemas.microsoft.com/office/powerpoint/2010/main" val="4135607998"/>
+      </p:ext>
+    </p:extLst>
+  </p:cSld>
+  <p:clrMapOvr>
+    <a:masterClrMapping/>
+  </p:clrMapOvr>
+</p:sld>
+</file>
+
+<file path=ppt/slides/slide4.xml><?xml version="1.0" encoding="utf-8"?>
+<p:sld xmlns:a="http://schemas.openxmlformats.org/drawingml/2006/main" xmlns:r="http://schemas.openxmlformats.org/officeDocument/2006/relationships" xmlns:p="http://schemas.openxmlformats.org/presentationml/2006/main">
+  <p:cSld>
+    <p:spTree>
+      <p:nvGrpSpPr>
+        <p:cNvPr id="1" name=""/>
+        <p:cNvGrpSpPr/>
+        <p:nvPr/>
+      </p:nvGrpSpPr>
+      <p:grpSpPr>
+        <a:xfrm>
+          <a:off x="0" y="0"/>
+          <a:ext cx="0" cy="0"/>
+          <a:chOff x="0" y="0"/>
+          <a:chExt cx="0" cy="0"/>
+        </a:xfrm>
+      </p:grpSpPr>
+      <p:sp>
+        <p:nvSpPr>
+          <p:cNvPr id="2" name="Title 1">
+            <a:extLst>
+              <a:ext uri="{FF2B5EF4-FFF2-40B4-BE49-F238E27FC236}">
+                <a16:creationId xmlns:a16="http://schemas.microsoft.com/office/drawing/2014/main" id="{7C4359A6-238C-2040-D6C7-85D495801003}"/>
+              </a:ext>
+            </a:extLst>
+          </p:cNvPr>
+          <p:cNvSpPr>
+            <a:spLocks noGrp="1"/>
+          </p:cNvSpPr>
+          <p:nvPr>
+            <p:ph type="title"/>
+          </p:nvPr>
+        </p:nvSpPr>
+        <p:spPr/>
+        <p:txBody>
+          <a:bodyPr/>
+          <a:lstStyle/>
+          <a:p>
+            <a:endParaRPr lang="en-US"/>
+          </a:p>
+        </p:txBody>
+      </p:sp>
+      <p:pic>
+        <p:nvPicPr>
+          <p:cNvPr id="6" name="Content Placeholder 5" descr="A chart with different colored squares&#10;&#10;Description automatically generated">
+            <a:extLst>
+              <a:ext uri="{FF2B5EF4-FFF2-40B4-BE49-F238E27FC236}">
+                <a16:creationId xmlns:a16="http://schemas.microsoft.com/office/drawing/2014/main" id="{83E551F7-99FA-834D-8174-6905B53F0DBB}"/>
+              </a:ext>
+            </a:extLst>
+          </p:cNvPr>
+          <p:cNvPicPr>
+            <a:picLocks noGrp="1" noChangeAspect="1"/>
+          </p:cNvPicPr>
+          <p:nvPr>
+            <p:ph idx="1"/>
+          </p:nvPr>
+        </p:nvPicPr>
+        <p:blipFill>
+          <a:blip r:embed="rId2"/>
+          <a:stretch>
+            <a:fillRect/>
+          </a:stretch>
+        </p:blipFill>
+        <p:spPr>
+          <a:xfrm>
+            <a:off x="305233" y="1848774"/>
+            <a:ext cx="5076561" cy="4351338"/>
+          </a:xfrm>
+        </p:spPr>
+      </p:pic>
+      <p:pic>
+        <p:nvPicPr>
+          <p:cNvPr id="4" name="Picture 3">
+            <a:extLst>
+              <a:ext uri="{FF2B5EF4-FFF2-40B4-BE49-F238E27FC236}">
+                <a16:creationId xmlns:a16="http://schemas.microsoft.com/office/drawing/2014/main" id="{A4A3AFD6-55C1-BEE7-322D-B2CDC66CF055}"/>
+              </a:ext>
+            </a:extLst>
+          </p:cNvPr>
+          <p:cNvPicPr>
+            <a:picLocks noChangeAspect="1"/>
+          </p:cNvPicPr>
+          <p:nvPr/>
+        </p:nvPicPr>
+        <p:blipFill>
+          <a:blip r:embed="rId3"/>
+          <a:stretch>
+            <a:fillRect/>
+          </a:stretch>
+        </p:blipFill>
+        <p:spPr>
+          <a:xfrm>
+            <a:off x="5647481" y="1848774"/>
+            <a:ext cx="5232722" cy="4186178"/>
+          </a:xfrm>
+          <a:prstGeom prst="rect">
+            <a:avLst/>
+          </a:prstGeom>
+        </p:spPr>
+      </p:pic>
+    </p:spTree>
+    <p:extLst>
+      <p:ext uri="{BB962C8B-B14F-4D97-AF65-F5344CB8AC3E}">
+        <p14:creationId xmlns:p14="http://schemas.microsoft.com/office/powerpoint/2010/main" val="1279404584"/>
+      </p:ext>
+    </p:extLst>
+  </p:cSld>
+  <p:clrMapOvr>
+    <a:masterClrMapping/>
+  </p:clrMapOvr>
+</p:sld>
+</file>
+
+<file path=ppt/slides/slide5.xml><?xml version="1.0" encoding="utf-8"?>
+<p:sld xmlns:a="http://schemas.openxmlformats.org/drawingml/2006/main" xmlns:r="http://schemas.openxmlformats.org/officeDocument/2006/relationships" xmlns:p="http://schemas.openxmlformats.org/presentationml/2006/main">
+  <p:cSld>
+    <p:spTree>
+      <p:nvGrpSpPr>
+        <p:cNvPr id="1" name=""/>
+        <p:cNvGrpSpPr/>
+        <p:nvPr/>
+      </p:nvGrpSpPr>
+      <p:grpSpPr>
+        <a:xfrm>
+          <a:off x="0" y="0"/>
+          <a:ext cx="0" cy="0"/>
+          <a:chOff x="0" y="0"/>
+          <a:chExt cx="0" cy="0"/>
+        </a:xfrm>
+      </p:grpSpPr>
+      <p:sp>
+        <p:nvSpPr>
+          <p:cNvPr id="2" name="Title 1">
+            <a:extLst>
+              <a:ext uri="{FF2B5EF4-FFF2-40B4-BE49-F238E27FC236}">
+                <a16:creationId xmlns:a16="http://schemas.microsoft.com/office/drawing/2014/main" id="{B922A874-30D6-4466-8B7E-D6F28BF4C06D}"/>
+              </a:ext>
+            </a:extLst>
+          </p:cNvPr>
+          <p:cNvSpPr>
+            <a:spLocks noGrp="1"/>
+          </p:cNvSpPr>
+          <p:nvPr>
+            <p:ph type="title"/>
+          </p:nvPr>
+        </p:nvSpPr>
+        <p:spPr/>
+        <p:txBody>
+          <a:bodyPr/>
+          <a:lstStyle/>
+          <a:p>
+            <a:endParaRPr lang="en-US"/>
+          </a:p>
+        </p:txBody>
+      </p:sp>
+      <p:pic>
+        <p:nvPicPr>
+          <p:cNvPr id="4" name="Picture 3">
+            <a:extLst>
+              <a:ext uri="{FF2B5EF4-FFF2-40B4-BE49-F238E27FC236}">
+                <a16:creationId xmlns:a16="http://schemas.microsoft.com/office/drawing/2014/main" id="{EC7A25B9-9D76-0547-146A-FFBF33F600B8}"/>
+              </a:ext>
+            </a:extLst>
+          </p:cNvPr>
+          <p:cNvPicPr>
+            <a:picLocks noChangeAspect="1"/>
+          </p:cNvPicPr>
+          <p:nvPr/>
+        </p:nvPicPr>
+        <p:blipFill>
+          <a:blip r:embed="rId2"/>
+          <a:stretch>
+            <a:fillRect/>
+          </a:stretch>
+        </p:blipFill>
+        <p:spPr>
+          <a:xfrm>
+            <a:off x="6234703" y="690563"/>
+            <a:ext cx="5654040" cy="4846320"/>
+          </a:xfrm>
+          <a:prstGeom prst="rect">
+            <a:avLst/>
+          </a:prstGeom>
+        </p:spPr>
+      </p:pic>
+      <p:pic>
+        <p:nvPicPr>
+          <p:cNvPr id="5" name="Picture 4">
+            <a:extLst>
+              <a:ext uri="{FF2B5EF4-FFF2-40B4-BE49-F238E27FC236}">
+                <a16:creationId xmlns:a16="http://schemas.microsoft.com/office/drawing/2014/main" id="{F4576FD0-E099-8B56-5E77-E0E6E869AAD1}"/>
+              </a:ext>
+            </a:extLst>
+          </p:cNvPr>
+          <p:cNvPicPr>
+            <a:picLocks noChangeAspect="1"/>
+          </p:cNvPicPr>
+          <p:nvPr/>
+        </p:nvPicPr>
+        <p:blipFill>
+          <a:blip r:embed="rId3"/>
+          <a:stretch>
+            <a:fillRect/>
+          </a:stretch>
+        </p:blipFill>
+        <p:spPr>
+          <a:xfrm>
+            <a:off x="441960" y="690563"/>
+            <a:ext cx="5654040" cy="4846320"/>
+          </a:xfrm>
+          <a:prstGeom prst="rect">
+            <a:avLst/>
+          </a:prstGeom>
+        </p:spPr>
+      </p:pic>
+    </p:spTree>
+    <p:extLst>
+      <p:ext uri="{BB962C8B-B14F-4D97-AF65-F5344CB8AC3E}">
+        <p14:creationId xmlns:p14="http://schemas.microsoft.com/office/powerpoint/2010/main" val="141514905"/>
+      </p:ext>
+    </p:extLst>
+  </p:cSld>
+  <p:clrMapOvr>
+    <a:masterClrMapping/>
+  </p:clrMapOvr>
+</p:sld>
+</file>
+
+<file path=ppt/slides/slide6.xml><?xml version="1.0" encoding="utf-8"?>
+<p:sld xmlns:a="http://schemas.openxmlformats.org/drawingml/2006/main" xmlns:r="http://schemas.openxmlformats.org/officeDocument/2006/relationships" xmlns:p="http://schemas.openxmlformats.org/presentationml/2006/main">
+  <p:cSld>
+    <p:spTree>
+      <p:nvGrpSpPr>
+        <p:cNvPr id="1" name=""/>
+        <p:cNvGrpSpPr/>
+        <p:nvPr/>
+      </p:nvGrpSpPr>
+      <p:grpSpPr>
+        <a:xfrm>
+          <a:off x="0" y="0"/>
+          <a:ext cx="0" cy="0"/>
+          <a:chOff x="0" y="0"/>
+          <a:chExt cx="0" cy="0"/>
+        </a:xfrm>
+      </p:grpSpPr>
+      <p:pic>
+        <p:nvPicPr>
+          <p:cNvPr id="5" name="Picture 4" descr="A chart with different colored squares&#10;&#10;Description automatically generated">
+            <a:extLst>
+              <a:ext uri="{FF2B5EF4-FFF2-40B4-BE49-F238E27FC236}">
+                <a16:creationId xmlns:a16="http://schemas.microsoft.com/office/drawing/2014/main" id="{AA2DD25E-098B-3B11-0BE0-50BEE0E4B2DC}"/>
+              </a:ext>
+            </a:extLst>
+          </p:cNvPr>
+          <p:cNvPicPr>
+            <a:picLocks noChangeAspect="1"/>
+          </p:cNvPicPr>
+          <p:nvPr/>
+        </p:nvPicPr>
+        <p:blipFill>
+          <a:blip r:embed="rId2"/>
+          <a:stretch>
+            <a:fillRect/>
+          </a:stretch>
+        </p:blipFill>
+        <p:spPr>
+          <a:xfrm>
+            <a:off x="0" y="1"/>
+            <a:ext cx="4114800" cy="3526975"/>
+          </a:xfrm>
+          <a:prstGeom prst="rect">
+            <a:avLst/>
+          </a:prstGeom>
+        </p:spPr>
+      </p:pic>
+      <p:pic>
+        <p:nvPicPr>
+          <p:cNvPr id="7" name="Picture 6" descr="A chart with different colored squares&#10;&#10;Description automatically generated">
+            <a:extLst>
+              <a:ext uri="{FF2B5EF4-FFF2-40B4-BE49-F238E27FC236}">
+                <a16:creationId xmlns:a16="http://schemas.microsoft.com/office/drawing/2014/main" id="{EE846EC2-E6CB-8CBC-C1DC-EFA949FC9892}"/>
+              </a:ext>
+            </a:extLst>
+          </p:cNvPr>
+          <p:cNvPicPr>
+            <a:picLocks noChangeAspect="1"/>
+          </p:cNvPicPr>
+          <p:nvPr/>
+        </p:nvPicPr>
+        <p:blipFill>
+          <a:blip r:embed="rId3"/>
+          <a:stretch>
+            <a:fillRect/>
+          </a:stretch>
+        </p:blipFill>
+        <p:spPr>
+          <a:xfrm>
+            <a:off x="4038600" y="0"/>
+            <a:ext cx="4114800" cy="3526975"/>
+          </a:xfrm>
+          <a:prstGeom prst="rect">
+            <a:avLst/>
+          </a:prstGeom>
+        </p:spPr>
+      </p:pic>
+      <p:pic>
+        <p:nvPicPr>
+          <p:cNvPr id="9" name="Picture 8" descr="A chart with different colored squares&#10;&#10;Description automatically generated">
+            <a:extLst>
+              <a:ext uri="{FF2B5EF4-FFF2-40B4-BE49-F238E27FC236}">
+                <a16:creationId xmlns:a16="http://schemas.microsoft.com/office/drawing/2014/main" id="{94C036AE-D5AD-E23B-43DA-506CBBC96124}"/>
+              </a:ext>
+            </a:extLst>
+          </p:cNvPr>
+          <p:cNvPicPr>
+            <a:picLocks noChangeAspect="1"/>
+          </p:cNvPicPr>
+          <p:nvPr/>
+        </p:nvPicPr>
+        <p:blipFill>
+          <a:blip r:embed="rId4"/>
+          <a:stretch>
+            <a:fillRect/>
+          </a:stretch>
+        </p:blipFill>
+        <p:spPr>
+          <a:xfrm>
+            <a:off x="8077200" y="1"/>
+            <a:ext cx="4114800" cy="3526975"/>
+          </a:xfrm>
+          <a:prstGeom prst="rect">
+            <a:avLst/>
+          </a:prstGeom>
+        </p:spPr>
+      </p:pic>
+      <p:pic>
+        <p:nvPicPr>
+          <p:cNvPr id="11" name="Picture 10" descr="A chart with different colored squares&#10;&#10;Description automatically generated">
+            <a:extLst>
+              <a:ext uri="{FF2B5EF4-FFF2-40B4-BE49-F238E27FC236}">
+                <a16:creationId xmlns:a16="http://schemas.microsoft.com/office/drawing/2014/main" id="{9333594D-D426-19F8-AAC5-6D9C3916DD50}"/>
+              </a:ext>
+            </a:extLst>
+          </p:cNvPr>
+          <p:cNvPicPr>
+            <a:picLocks noChangeAspect="1"/>
+          </p:cNvPicPr>
+          <p:nvPr/>
+        </p:nvPicPr>
+        <p:blipFill>
+          <a:blip r:embed="rId5"/>
+          <a:stretch>
+            <a:fillRect/>
+          </a:stretch>
+        </p:blipFill>
+        <p:spPr>
+          <a:xfrm>
+            <a:off x="0" y="3351668"/>
+            <a:ext cx="4114800" cy="3526975"/>
+          </a:xfrm>
+          <a:prstGeom prst="rect">
+            <a:avLst/>
+          </a:prstGeom>
+        </p:spPr>
+      </p:pic>
+      <p:pic>
+        <p:nvPicPr>
+          <p:cNvPr id="13" name="Picture 12" descr="A chart with different colored squares&#10;&#10;Description automatically generated">
+            <a:extLst>
+              <a:ext uri="{FF2B5EF4-FFF2-40B4-BE49-F238E27FC236}">
+                <a16:creationId xmlns:a16="http://schemas.microsoft.com/office/drawing/2014/main" id="{CB219BC4-A952-3184-6CA5-FAFFEF3DE939}"/>
+              </a:ext>
+            </a:extLst>
+          </p:cNvPr>
+          <p:cNvPicPr>
+            <a:picLocks noChangeAspect="1"/>
+          </p:cNvPicPr>
+          <p:nvPr/>
+        </p:nvPicPr>
+        <p:blipFill>
+          <a:blip r:embed="rId6"/>
+          <a:stretch>
+            <a:fillRect/>
+          </a:stretch>
+        </p:blipFill>
+        <p:spPr>
+          <a:xfrm>
+            <a:off x="4114800" y="3351668"/>
+            <a:ext cx="4114800" cy="3526975"/>
+          </a:xfrm>
+          <a:prstGeom prst="rect">
+            <a:avLst/>
+          </a:prstGeom>
+        </p:spPr>
+      </p:pic>
+      <p:pic>
+        <p:nvPicPr>
+          <p:cNvPr id="15" name="Picture 14" descr="A chart with different colored squares&#10;&#10;Description automatically generated">
+            <a:extLst>
+              <a:ext uri="{FF2B5EF4-FFF2-40B4-BE49-F238E27FC236}">
+                <a16:creationId xmlns:a16="http://schemas.microsoft.com/office/drawing/2014/main" id="{68C5A217-6320-6D6C-CD53-8EB75461331C}"/>
+              </a:ext>
+            </a:extLst>
+          </p:cNvPr>
+          <p:cNvPicPr>
+            <a:picLocks noChangeAspect="1"/>
+          </p:cNvPicPr>
+          <p:nvPr/>
+        </p:nvPicPr>
+        <p:blipFill>
+          <a:blip r:embed="rId7"/>
+          <a:stretch>
+            <a:fillRect/>
+          </a:stretch>
+        </p:blipFill>
+        <p:spPr>
+          <a:xfrm>
+            <a:off x="8077200" y="3351668"/>
+            <a:ext cx="4114800" cy="3526975"/>
+          </a:xfrm>
+          <a:prstGeom prst="rect">
+            <a:avLst/>
+          </a:prstGeom>
+        </p:spPr>
+      </p:pic>
+    </p:spTree>
+    <p:extLst>
+      <p:ext uri="{BB962C8B-B14F-4D97-AF65-F5344CB8AC3E}">
+        <p14:creationId xmlns:p14="http://schemas.microsoft.com/office/powerpoint/2010/main" val="2061912280"/>
+      </p:ext>
+    </p:extLst>
+  </p:cSld>
+  <p:clrMapOvr>
+    <a:masterClrMapping/>
+  </p:clrMapOvr>
+</p:sld>
+</file>
+
+<file path=ppt/slides/slide7.xml><?xml version="1.0" encoding="utf-8"?>
+<p:sld xmlns:a="http://schemas.openxmlformats.org/drawingml/2006/main" xmlns:r="http://schemas.openxmlformats.org/officeDocument/2006/relationships" xmlns:p="http://schemas.openxmlformats.org/presentationml/2006/main">
+  <p:cSld>
+    <p:spTree>
+      <p:nvGrpSpPr>
+        <p:cNvPr id="1" name=""/>
+        <p:cNvGrpSpPr/>
+        <p:nvPr/>
+      </p:nvGrpSpPr>
+      <p:grpSpPr>
+        <a:xfrm>
+          <a:off x="0" y="0"/>
+          <a:ext cx="0" cy="0"/>
+          <a:chOff x="0" y="0"/>
+          <a:chExt cx="0" cy="0"/>
+        </a:xfrm>
+      </p:grpSpPr>
+      <p:pic>
+        <p:nvPicPr>
+          <p:cNvPr id="5" name="Picture 4" descr="A chart with different colored squares&#10;&#10;Description automatically generated">
+            <a:extLst>
+              <a:ext uri="{FF2B5EF4-FFF2-40B4-BE49-F238E27FC236}">
+                <a16:creationId xmlns:a16="http://schemas.microsoft.com/office/drawing/2014/main" id="{AA77F91D-F39A-8A2A-06EC-4E586910479C}"/>
+              </a:ext>
+            </a:extLst>
+          </p:cNvPr>
+          <p:cNvPicPr>
+            <a:picLocks noChangeAspect="1"/>
+          </p:cNvPicPr>
+          <p:nvPr/>
+        </p:nvPicPr>
+        <p:blipFill>
+          <a:blip r:embed="rId2"/>
+          <a:stretch>
+            <a:fillRect/>
+          </a:stretch>
+        </p:blipFill>
+        <p:spPr>
+          <a:xfrm>
+            <a:off x="0" y="960120"/>
+            <a:ext cx="5760720" cy="4937760"/>
+          </a:xfrm>
+          <a:prstGeom prst="rect">
+            <a:avLst/>
+          </a:prstGeom>
+        </p:spPr>
+      </p:pic>
+      <p:pic>
+        <p:nvPicPr>
+          <p:cNvPr id="7" name="Picture 6" descr="A graph with blue and white text&#10;&#10;Description automatically generated">
+            <a:extLst>
+              <a:ext uri="{FF2B5EF4-FFF2-40B4-BE49-F238E27FC236}">
+                <a16:creationId xmlns:a16="http://schemas.microsoft.com/office/drawing/2014/main" id="{771EA53B-AB1A-54EA-3C4B-5105C6DF5EE1}"/>
+              </a:ext>
+            </a:extLst>
+          </p:cNvPr>
+          <p:cNvPicPr>
+            <a:picLocks noChangeAspect="1"/>
+          </p:cNvPicPr>
+          <p:nvPr/>
+        </p:nvPicPr>
+        <p:blipFill>
+          <a:blip r:embed="rId3"/>
+          <a:stretch>
+            <a:fillRect/>
+          </a:stretch>
+        </p:blipFill>
+        <p:spPr>
+          <a:xfrm>
+            <a:off x="5888042" y="960120"/>
+            <a:ext cx="6172200" cy="4937760"/>
+          </a:xfrm>
+          <a:prstGeom prst="rect">
+            <a:avLst/>
+          </a:prstGeom>
+        </p:spPr>
+      </p:pic>
+    </p:spTree>
+    <p:extLst>
+      <p:ext uri="{BB962C8B-B14F-4D97-AF65-F5344CB8AC3E}">
+        <p14:creationId xmlns:p14="http://schemas.microsoft.com/office/powerpoint/2010/main" val="988793364"/>
+      </p:ext>
+    </p:extLst>
+  </p:cSld>
+  <p:clrMapOvr>
+    <a:masterClrMapping/>
+  </p:clrMapOvr>
+</p:sld>
+</file>
+
+<file path=ppt/slides/slide8.xml><?xml version="1.0" encoding="utf-8"?>
+<p:sld xmlns:a="http://schemas.openxmlformats.org/drawingml/2006/main" xmlns:r="http://schemas.openxmlformats.org/officeDocument/2006/relationships" xmlns:p="http://schemas.openxmlformats.org/presentationml/2006/main">
+  <p:cSld>
+    <p:spTree>
+      <p:nvGrpSpPr>
+        <p:cNvPr id="1" name=""/>
+        <p:cNvGrpSpPr/>
+        <p:nvPr/>
+      </p:nvGrpSpPr>
+      <p:grpSpPr>
+        <a:xfrm>
+          <a:off x="0" y="0"/>
+          <a:ext cx="0" cy="0"/>
+          <a:chOff x="0" y="0"/>
+          <a:chExt cx="0" cy="0"/>
+        </a:xfrm>
+      </p:grpSpPr>
+      <p:pic>
+        <p:nvPicPr>
+          <p:cNvPr id="5" name="Picture 4" descr="A colorful squares with numbers&#10;&#10;Description automatically generated">
+            <a:extLst>
+              <a:ext uri="{FF2B5EF4-FFF2-40B4-BE49-F238E27FC236}">
+                <a16:creationId xmlns:a16="http://schemas.microsoft.com/office/drawing/2014/main" id="{319E067C-AE72-02EA-CB90-8286C1FB6460}"/>
+              </a:ext>
+            </a:extLst>
+          </p:cNvPr>
+          <p:cNvPicPr>
+            <a:picLocks noChangeAspect="1"/>
+          </p:cNvPicPr>
+          <p:nvPr/>
+        </p:nvPicPr>
+        <p:blipFill>
+          <a:blip r:embed="rId2"/>
+          <a:stretch>
+            <a:fillRect/>
+          </a:stretch>
+        </p:blipFill>
+        <p:spPr>
+          <a:xfrm>
+            <a:off x="0" y="914400"/>
+            <a:ext cx="5867400" cy="5029200"/>
+          </a:xfrm>
+          <a:prstGeom prst="rect">
+            <a:avLst/>
+          </a:prstGeom>
+        </p:spPr>
+      </p:pic>
+      <p:pic>
+        <p:nvPicPr>
+          <p:cNvPr id="7" name="Picture 6" descr="A graph with blue and white text&#10;&#10;Description automatically generated">
+            <a:extLst>
+              <a:ext uri="{FF2B5EF4-FFF2-40B4-BE49-F238E27FC236}">
+                <a16:creationId xmlns:a16="http://schemas.microsoft.com/office/drawing/2014/main" id="{1983A2A1-2297-B9E1-A6FA-99921D7B2FA8}"/>
+              </a:ext>
+            </a:extLst>
+          </p:cNvPr>
+          <p:cNvPicPr>
+            <a:picLocks noChangeAspect="1"/>
+          </p:cNvPicPr>
+          <p:nvPr/>
+        </p:nvPicPr>
+        <p:blipFill>
+          <a:blip r:embed="rId3"/>
+          <a:stretch>
+            <a:fillRect/>
+          </a:stretch>
+        </p:blipFill>
+        <p:spPr>
+          <a:xfrm>
+            <a:off x="5756246" y="914400"/>
+            <a:ext cx="6286500" cy="5029200"/>
+          </a:xfrm>
+          <a:prstGeom prst="rect">
+            <a:avLst/>
+          </a:prstGeom>
+        </p:spPr>
+      </p:pic>
+    </p:spTree>
+    <p:extLst>
+      <p:ext uri="{BB962C8B-B14F-4D97-AF65-F5344CB8AC3E}">
+        <p14:creationId xmlns:p14="http://schemas.microsoft.com/office/powerpoint/2010/main" val="3236970989"/>
+      </p:ext>
+    </p:extLst>
+  </p:cSld>
+  <p:clrMapOvr>
+    <a:masterClrMapping/>
+  </p:clrMapOvr>
+</p:sld>
+</file>
+
+<file path=ppt/slides/slide9.xml><?xml version="1.0" encoding="utf-8"?>
+<p:sld xmlns:a="http://schemas.openxmlformats.org/drawingml/2006/main" xmlns:r="http://schemas.openxmlformats.org/officeDocument/2006/relationships" xmlns:p="http://schemas.openxmlformats.org/presentationml/2006/main">
+  <p:cSld>
+    <p:spTree>
+      <p:nvGrpSpPr>
+        <p:cNvPr id="1" name=""/>
+        <p:cNvGrpSpPr/>
+        <p:nvPr/>
+      </p:nvGrpSpPr>
+      <p:grpSpPr>
+        <a:xfrm>
+          <a:off x="0" y="0"/>
+          <a:ext cx="0" cy="0"/>
+          <a:chOff x="0" y="0"/>
+          <a:chExt cx="0" cy="0"/>
+        </a:xfrm>
+      </p:grpSpPr>
+      <p:pic>
+        <p:nvPicPr>
+          <p:cNvPr id="5" name="Picture 4">
+            <a:extLst>
+              <a:ext uri="{FF2B5EF4-FFF2-40B4-BE49-F238E27FC236}">
+                <a16:creationId xmlns:a16="http://schemas.microsoft.com/office/drawing/2014/main" id="{30E08C22-8F44-DB1D-0F1B-D7691D5285D5}"/>
+              </a:ext>
+            </a:extLst>
+          </p:cNvPr>
+          <p:cNvPicPr>
+            <a:picLocks noChangeAspect="1"/>
+          </p:cNvPicPr>
+          <p:nvPr/>
+        </p:nvPicPr>
+        <p:blipFill>
+          <a:blip r:embed="rId2"/>
+          <a:stretch>
+            <a:fillRect/>
+          </a:stretch>
+        </p:blipFill>
+        <p:spPr>
+          <a:xfrm>
+            <a:off x="2812061" y="0"/>
+            <a:ext cx="4279392" cy="3566160"/>
+          </a:xfrm>
+          <a:prstGeom prst="rect">
+            <a:avLst/>
+          </a:prstGeom>
+        </p:spPr>
+      </p:pic>
+      <p:pic>
+        <p:nvPicPr>
+          <p:cNvPr id="7" name="Picture 6">
+            <a:extLst>
+              <a:ext uri="{FF2B5EF4-FFF2-40B4-BE49-F238E27FC236}">
+                <a16:creationId xmlns:a16="http://schemas.microsoft.com/office/drawing/2014/main" id="{E145F703-5C57-0509-B665-A1AE20ECC1E6}"/>
+              </a:ext>
+            </a:extLst>
+          </p:cNvPr>
+          <p:cNvPicPr>
+            <a:picLocks noChangeAspect="1"/>
+          </p:cNvPicPr>
+          <p:nvPr/>
+        </p:nvPicPr>
+        <p:blipFill>
+          <a:blip r:embed="rId3"/>
+          <a:stretch>
+            <a:fillRect/>
+          </a:stretch>
+        </p:blipFill>
+        <p:spPr>
+          <a:xfrm>
+            <a:off x="2812061" y="3566160"/>
+            <a:ext cx="4114800" cy="3291840"/>
+          </a:xfrm>
+          <a:prstGeom prst="rect">
+            <a:avLst/>
+          </a:prstGeom>
+        </p:spPr>
+      </p:pic>
+      <p:pic>
+        <p:nvPicPr>
+          <p:cNvPr id="9" name="Picture 8">
+            <a:extLst>
+              <a:ext uri="{FF2B5EF4-FFF2-40B4-BE49-F238E27FC236}">
+                <a16:creationId xmlns:a16="http://schemas.microsoft.com/office/drawing/2014/main" id="{D97F14B0-546D-80D7-16E9-7E029C74FBE0}"/>
+              </a:ext>
+            </a:extLst>
+          </p:cNvPr>
+          <p:cNvPicPr>
+            <a:picLocks noChangeAspect="1"/>
+          </p:cNvPicPr>
+          <p:nvPr/>
+        </p:nvPicPr>
+        <p:blipFill>
+          <a:blip r:embed="rId4"/>
+          <a:stretch>
+            <a:fillRect/>
+          </a:stretch>
+        </p:blipFill>
+        <p:spPr>
+          <a:xfrm>
+            <a:off x="7750430" y="0"/>
+            <a:ext cx="4160520" cy="3566160"/>
+          </a:xfrm>
+          <a:prstGeom prst="rect">
+            <a:avLst/>
+          </a:prstGeom>
+        </p:spPr>
+      </p:pic>
+      <p:pic>
+        <p:nvPicPr>
+          <p:cNvPr id="11" name="Picture 10">
+            <a:extLst>
+              <a:ext uri="{FF2B5EF4-FFF2-40B4-BE49-F238E27FC236}">
+                <a16:creationId xmlns:a16="http://schemas.microsoft.com/office/drawing/2014/main" id="{BF168083-4B0E-AC84-3727-10440D9C83EF}"/>
+              </a:ext>
+            </a:extLst>
+          </p:cNvPr>
+          <p:cNvPicPr>
+            <a:picLocks noChangeAspect="1"/>
+          </p:cNvPicPr>
+          <p:nvPr/>
+        </p:nvPicPr>
+        <p:blipFill>
+          <a:blip r:embed="rId5"/>
+          <a:stretch>
+            <a:fillRect/>
+          </a:stretch>
+        </p:blipFill>
+        <p:spPr>
+          <a:xfrm>
+            <a:off x="7750430" y="3566160"/>
+            <a:ext cx="4114800" cy="3291840"/>
+          </a:xfrm>
+          <a:prstGeom prst="rect">
+            <a:avLst/>
+          </a:prstGeom>
+        </p:spPr>
+      </p:pic>
+      <p:sp>
+        <p:nvSpPr>
+          <p:cNvPr id="12" name="TextBox 11">
+            <a:extLst>
+              <a:ext uri="{FF2B5EF4-FFF2-40B4-BE49-F238E27FC236}">
+                <a16:creationId xmlns:a16="http://schemas.microsoft.com/office/drawing/2014/main" id="{C21EBF00-84F6-CBFD-5BF2-051439152864}"/>
+              </a:ext>
+            </a:extLst>
+          </p:cNvPr>
+          <p:cNvSpPr txBox="1"/>
+          <p:nvPr/>
+        </p:nvSpPr>
+        <p:spPr>
+          <a:xfrm>
+            <a:off x="83681" y="3196828"/>
+            <a:ext cx="2698239" cy="400110"/>
+          </a:xfrm>
+          <a:prstGeom prst="rect">
+            <a:avLst/>
+          </a:prstGeom>
+          <a:noFill/>
+        </p:spPr>
+        <p:txBody>
+          <a:bodyPr wrap="none" rtlCol="0">
+            <a:spAutoFit/>
+          </a:bodyPr>
+          <a:lstStyle/>
+          <a:p>
+            <a:r>
+              <a:rPr lang="en-US" sz="2000" b="1" dirty="0"/>
+              <a:t>Pre-selected pictures</a:t>
+            </a:r>
+          </a:p>
+        </p:txBody>
+      </p:sp>
+    </p:spTree>
+    <p:extLst>
+      <p:ext uri="{BB962C8B-B14F-4D97-AF65-F5344CB8AC3E}">
+        <p14:creationId xmlns:p14="http://schemas.microsoft.com/office/powerpoint/2010/main" val="1949982530"/>
       </p:ext>
     </p:extLst>
   </p:cSld>

</xml_diff>